<commit_message>
Polish pitch deck: consistent title sizes and pillar color language
- Unified all list-style content-slide headers to 28pt (previously varied
  26-34pt with no clear reason).
- Fixed a real color inconsistency: the Fraud & Stress pillar was tagged
  green (SUCCESS) on the Challenge slide but red (DANGER) everywhere else
  it appears (pillar cards, section header, hard-rules table). Now DANGER
  consistently, matching the risk-toned semantics everywhere else.
- Applied the same 3-color pillar language (Fraud=red, Personalization=
  blue, Vernacular=gold) to the architecture diagram's output nodes and
  the solution-overview pillar icons, which previously used unrelated
  colors (gold/green) for the same two pillars.
- Tightened three slides that measured out with too little clearance
  above the footer (Challenge, Architecture caption, Judging Criteria).

Co-Authored-By: Claude Sonnet 5 <noreply@anthropic.com>
Claude-Session: https://claude.ai/code/session_01PAwD4dtuQr1Z3ZKHFLwVez
</commit_message>
<xml_diff>
--- a/docs/MISP_Bank_Pitch_Deck.pptx
+++ b/docs/MISP_Bank_Pitch_Deck.pptx
@@ -6132,7 +6132,7 @@
           <a:p>
             <a:pPr algn="l"/>
             <a:r>
-              <a:rPr sz="2700" b="1" i="0">
+              <a:rPr sz="2800" b="1" i="0">
                 <a:solidFill>
                   <a:srgbClr val="0A2547"/>
                 </a:solidFill>
@@ -9278,7 +9278,7 @@
           <a:p>
             <a:pPr algn="l"/>
             <a:r>
-              <a:rPr sz="3400" b="1" i="0">
+              <a:rPr sz="2800" b="1" i="0">
                 <a:solidFill>
                   <a:srgbClr val="0A2547"/>
                 </a:solidFill>
@@ -10108,7 +10108,7 @@
           <a:p>
             <a:pPr algn="l"/>
             <a:r>
-              <a:rPr sz="3000" b="1" i="0">
+              <a:rPr sz="2800" b="1" i="0">
                 <a:solidFill>
                   <a:srgbClr val="0A2547"/>
                 </a:solidFill>
@@ -10634,7 +10634,7 @@
             </a:avLst>
           </a:prstGeom>
           <a:solidFill>
-            <a:srgbClr val="1F8A51"/>
+            <a:srgbClr val="C0392B"/>
           </a:solidFill>
           <a:ln>
             <a:noFill/>
@@ -10804,7 +10804,7 @@
           </a:solidFill>
           <a:ln w="19050">
             <a:solidFill>
-              <a:srgbClr val="1F8A51"/>
+              <a:srgbClr val="C0392B"/>
             </a:solidFill>
           </a:ln>
           <a:effectLst/>
@@ -10857,7 +10857,7 @@
             <a:r>
               <a:rPr sz="1350" b="1" i="0">
                 <a:solidFill>
-                  <a:srgbClr val="1F8A51"/>
+                  <a:srgbClr val="C0392B"/>
                 </a:solidFill>
                 <a:latin typeface="Segoe UI"/>
               </a:rPr>
@@ -11168,7 +11168,7 @@
             <a:avLst/>
           </a:prstGeom>
           <a:solidFill>
-            <a:srgbClr val="0B57B0"/>
+            <a:srgbClr val="C0392B"/>
           </a:solidFill>
           <a:ln>
             <a:noFill/>
@@ -11574,7 +11574,7 @@
             <a:avLst/>
           </a:prstGeom>
           <a:solidFill>
-            <a:srgbClr val="0B57B0"/>
+            <a:srgbClr val="B3791F"/>
           </a:solidFill>
           <a:ln>
             <a:noFill/>
@@ -11836,7 +11836,7 @@
           <a:p>
             <a:pPr algn="l"/>
             <a:r>
-              <a:rPr sz="2600" b="1" i="0">
+              <a:rPr sz="2800" b="1" i="0">
                 <a:solidFill>
                   <a:srgbClr val="0A2547"/>
                 </a:solidFill>
@@ -12831,7 +12831,7 @@
             </a:avLst>
           </a:prstGeom>
           <a:solidFill>
-            <a:srgbClr val="B3791F"/>
+            <a:srgbClr val="0B57B0"/>
           </a:solidFill>
           <a:ln>
             <a:noFill/>
@@ -12932,7 +12932,7 @@
             </a:avLst>
           </a:prstGeom>
           <a:solidFill>
-            <a:srgbClr val="1F8A51"/>
+            <a:srgbClr val="B3791F"/>
           </a:solidFill>
           <a:ln>
             <a:noFill/>
@@ -13422,7 +13422,7 @@
           <a:p>
             <a:pPr algn="l"/>
             <a:r>
-              <a:rPr sz="2600" b="1" i="0">
+              <a:rPr sz="2800" b="1" i="0">
                 <a:solidFill>
                   <a:srgbClr val="0A2547"/>
                 </a:solidFill>
@@ -14586,7 +14586,7 @@
           <a:p>
             <a:pPr algn="l"/>
             <a:r>
-              <a:rPr sz="2600" b="1" i="0">
+              <a:rPr sz="2800" b="1" i="0">
                 <a:solidFill>
                   <a:srgbClr val="0A2547"/>
                 </a:solidFill>
@@ -15783,7 +15783,7 @@
           <a:p>
             <a:pPr algn="l"/>
             <a:r>
-              <a:rPr sz="2600" b="1" i="0">
+              <a:rPr sz="2800" b="1" i="0">
                 <a:solidFill>
                   <a:srgbClr val="0A2547"/>
                 </a:solidFill>

</xml_diff>